<commit_message>
tidy up files and debug comp gap for correlated decoding
</commit_message>
<xml_diff>
--- a/paper_diagrams/paper_scratch_images.pptx
+++ b/paper_diagrams/paper_scratch_images.pptx
@@ -5,7 +5,7 @@
     <p:sldMasterId id="2147483648" r:id="rId1"/>
   </p:sldMasterIdLst>
   <p:notesMasterIdLst>
-    <p:notesMasterId r:id="rId23"/>
+    <p:notesMasterId r:id="rId28"/>
   </p:notesMasterIdLst>
   <p:sldIdLst>
     <p:sldId id="257" r:id="rId2"/>
@@ -29,6 +29,11 @@
     <p:sldId id="274" r:id="rId20"/>
     <p:sldId id="278" r:id="rId21"/>
     <p:sldId id="279" r:id="rId22"/>
+    <p:sldId id="280" r:id="rId23"/>
+    <p:sldId id="281" r:id="rId24"/>
+    <p:sldId id="282" r:id="rId25"/>
+    <p:sldId id="283" r:id="rId26"/>
+    <p:sldId id="284" r:id="rId27"/>
   </p:sldIdLst>
   <p:sldSz cx="12192000" cy="6858000"/>
   <p:notesSz cx="6858000" cy="9144000"/>
@@ -18954,6 +18959,1845 @@
     <p:extLst>
       <p:ext uri="{BB962C8B-B14F-4D97-AF65-F5344CB8AC3E}">
         <p14:creationId xmlns:p14="http://schemas.microsoft.com/office/powerpoint/2010/main" val="1335487649"/>
+      </p:ext>
+    </p:extLst>
+  </p:cSld>
+  <p:clrMapOvr>
+    <a:masterClrMapping/>
+  </p:clrMapOvr>
+</p:sld>
+</file>
+
+<file path=ppt/slides/slide22.xml><?xml version="1.0" encoding="utf-8"?>
+<p:sld xmlns:a="http://schemas.openxmlformats.org/drawingml/2006/main" xmlns:r="http://schemas.openxmlformats.org/officeDocument/2006/relationships" xmlns:p="http://schemas.openxmlformats.org/presentationml/2006/main">
+  <p:cSld>
+    <p:spTree>
+      <p:nvGrpSpPr>
+        <p:cNvPr id="1" name="">
+          <a:extLst>
+            <a:ext uri="{FF2B5EF4-FFF2-40B4-BE49-F238E27FC236}">
+              <a16:creationId xmlns:a16="http://schemas.microsoft.com/office/drawing/2014/main" id="{28C142DC-E2D3-8EFD-F128-6253510CBFB9}"/>
+            </a:ext>
+          </a:extLst>
+        </p:cNvPr>
+        <p:cNvGrpSpPr/>
+        <p:nvPr/>
+      </p:nvGrpSpPr>
+      <p:grpSpPr>
+        <a:xfrm>
+          <a:off x="0" y="0"/>
+          <a:ext cx="0" cy="0"/>
+          <a:chOff x="0" y="0"/>
+          <a:chExt cx="0" cy="0"/>
+        </a:xfrm>
+      </p:grpSpPr>
+      <p:sp>
+        <p:nvSpPr>
+          <p:cNvPr id="2" name="Title 1">
+            <a:extLst>
+              <a:ext uri="{FF2B5EF4-FFF2-40B4-BE49-F238E27FC236}">
+                <a16:creationId xmlns:a16="http://schemas.microsoft.com/office/drawing/2014/main" id="{7C1837EE-663F-C702-06B4-01CCF75C67A1}"/>
+              </a:ext>
+            </a:extLst>
+          </p:cNvPr>
+          <p:cNvSpPr>
+            <a:spLocks noGrp="1"/>
+          </p:cNvSpPr>
+          <p:nvPr>
+            <p:ph type="ctrTitle"/>
+          </p:nvPr>
+        </p:nvSpPr>
+        <p:spPr/>
+        <p:txBody>
+          <a:bodyPr/>
+          <a:lstStyle/>
+          <a:p>
+            <a:r>
+              <a:rPr lang="en-US" dirty="0"/>
+              <a:t>Fig 12</a:t>
+            </a:r>
+          </a:p>
+        </p:txBody>
+      </p:sp>
+      <p:sp>
+        <p:nvSpPr>
+          <p:cNvPr id="3" name="Subtitle 2">
+            <a:extLst>
+              <a:ext uri="{FF2B5EF4-FFF2-40B4-BE49-F238E27FC236}">
+                <a16:creationId xmlns:a16="http://schemas.microsoft.com/office/drawing/2014/main" id="{EF75E62F-A017-B97F-CA51-BB4B1B3F6E47}"/>
+              </a:ext>
+            </a:extLst>
+          </p:cNvPr>
+          <p:cNvSpPr>
+            <a:spLocks noGrp="1"/>
+          </p:cNvSpPr>
+          <p:nvPr>
+            <p:ph type="subTitle" idx="1"/>
+          </p:nvPr>
+        </p:nvSpPr>
+        <p:spPr/>
+        <p:txBody>
+          <a:bodyPr/>
+          <a:lstStyle/>
+          <a:p>
+            <a:endParaRPr lang="en-US"/>
+          </a:p>
+        </p:txBody>
+      </p:sp>
+    </p:spTree>
+    <p:extLst>
+      <p:ext uri="{BB962C8B-B14F-4D97-AF65-F5344CB8AC3E}">
+        <p14:creationId xmlns:p14="http://schemas.microsoft.com/office/powerpoint/2010/main" val="3247404101"/>
+      </p:ext>
+    </p:extLst>
+  </p:cSld>
+  <p:clrMapOvr>
+    <a:masterClrMapping/>
+  </p:clrMapOvr>
+</p:sld>
+</file>
+
+<file path=ppt/slides/slide23.xml><?xml version="1.0" encoding="utf-8"?>
+<p:sld xmlns:a="http://schemas.openxmlformats.org/drawingml/2006/main" xmlns:r="http://schemas.openxmlformats.org/officeDocument/2006/relationships" xmlns:p="http://schemas.openxmlformats.org/presentationml/2006/main">
+  <p:cSld>
+    <p:spTree>
+      <p:nvGrpSpPr>
+        <p:cNvPr id="1" name=""/>
+        <p:cNvGrpSpPr/>
+        <p:nvPr/>
+      </p:nvGrpSpPr>
+      <p:grpSpPr>
+        <a:xfrm>
+          <a:off x="0" y="0"/>
+          <a:ext cx="0" cy="0"/>
+          <a:chOff x="0" y="0"/>
+          <a:chExt cx="0" cy="0"/>
+        </a:xfrm>
+      </p:grpSpPr>
+      <p:pic>
+        <p:nvPicPr>
+          <p:cNvPr id="3" name="Graphic 2">
+            <a:extLst>
+              <a:ext uri="{FF2B5EF4-FFF2-40B4-BE49-F238E27FC236}">
+                <a16:creationId xmlns:a16="http://schemas.microsoft.com/office/drawing/2014/main" id="{37D794FC-C74A-0678-1FD5-663AA742D5A3}"/>
+              </a:ext>
+            </a:extLst>
+          </p:cNvPr>
+          <p:cNvPicPr>
+            <a:picLocks noChangeAspect="1"/>
+          </p:cNvPicPr>
+          <p:nvPr/>
+        </p:nvPicPr>
+        <p:blipFill>
+          <a:blip>
+            <a:extLst>
+              <a:ext uri="{96DAC541-7B7A-43D3-8B79-37D633B846F1}">
+                <asvg:svgBlip xmlns:asvg="http://schemas.microsoft.com/office/drawing/2016/SVG/main" r:embed="rId2"/>
+              </a:ext>
+            </a:extLst>
+          </a:blip>
+          <a:srcRect r="12222" b="12456"/>
+          <a:stretch>
+            <a:fillRect/>
+          </a:stretch>
+        </p:blipFill>
+        <p:spPr>
+          <a:xfrm>
+            <a:off x="3086100" y="222583"/>
+            <a:ext cx="6019800" cy="6003757"/>
+          </a:xfrm>
+          <a:prstGeom prst="rect">
+            <a:avLst/>
+          </a:prstGeom>
+        </p:spPr>
+      </p:pic>
+      <p:sp>
+        <p:nvSpPr>
+          <p:cNvPr id="4" name="Oval 3">
+            <a:extLst>
+              <a:ext uri="{FF2B5EF4-FFF2-40B4-BE49-F238E27FC236}">
+                <a16:creationId xmlns:a16="http://schemas.microsoft.com/office/drawing/2014/main" id="{55CD478D-D567-21D9-90A0-66DF91ABBB45}"/>
+              </a:ext>
+            </a:extLst>
+          </p:cNvPr>
+          <p:cNvSpPr/>
+          <p:nvPr/>
+        </p:nvSpPr>
+        <p:spPr>
+          <a:xfrm>
+            <a:off x="2372397" y="2995863"/>
+            <a:ext cx="182880" cy="182880"/>
+          </a:xfrm>
+          <a:prstGeom prst="ellipse">
+            <a:avLst/>
+          </a:prstGeom>
+          <a:solidFill>
+            <a:schemeClr val="tx1"/>
+          </a:solidFill>
+          <a:ln>
+            <a:solidFill>
+              <a:schemeClr val="tx1"/>
+            </a:solidFill>
+          </a:ln>
+        </p:spPr>
+        <p:style>
+          <a:lnRef idx="2">
+            <a:schemeClr val="accent1">
+              <a:shade val="15000"/>
+            </a:schemeClr>
+          </a:lnRef>
+          <a:fillRef idx="1">
+            <a:schemeClr val="accent1"/>
+          </a:fillRef>
+          <a:effectRef idx="0">
+            <a:schemeClr val="accent1"/>
+          </a:effectRef>
+          <a:fontRef idx="minor">
+            <a:schemeClr val="lt1"/>
+          </a:fontRef>
+        </p:style>
+        <p:txBody>
+          <a:bodyPr rtlCol="0" anchor="ctr"/>
+          <a:lstStyle/>
+          <a:p>
+            <a:pPr algn="ctr"/>
+            <a:endParaRPr lang="en-US"/>
+          </a:p>
+        </p:txBody>
+      </p:sp>
+      <p:sp>
+        <p:nvSpPr>
+          <p:cNvPr id="5" name="Oval 4">
+            <a:extLst>
+              <a:ext uri="{FF2B5EF4-FFF2-40B4-BE49-F238E27FC236}">
+                <a16:creationId xmlns:a16="http://schemas.microsoft.com/office/drawing/2014/main" id="{D7767B6E-B6F7-0BE5-D45C-BCEF7F361D29}"/>
+              </a:ext>
+            </a:extLst>
+          </p:cNvPr>
+          <p:cNvSpPr/>
+          <p:nvPr/>
+        </p:nvSpPr>
+        <p:spPr>
+          <a:xfrm>
+            <a:off x="9799283" y="2995861"/>
+            <a:ext cx="182880" cy="182880"/>
+          </a:xfrm>
+          <a:prstGeom prst="ellipse">
+            <a:avLst/>
+          </a:prstGeom>
+          <a:solidFill>
+            <a:schemeClr val="tx1"/>
+          </a:solidFill>
+          <a:ln>
+            <a:solidFill>
+              <a:schemeClr val="tx1"/>
+            </a:solidFill>
+          </a:ln>
+        </p:spPr>
+        <p:style>
+          <a:lnRef idx="2">
+            <a:schemeClr val="accent1">
+              <a:shade val="15000"/>
+            </a:schemeClr>
+          </a:lnRef>
+          <a:fillRef idx="1">
+            <a:schemeClr val="accent1"/>
+          </a:fillRef>
+          <a:effectRef idx="0">
+            <a:schemeClr val="accent1"/>
+          </a:effectRef>
+          <a:fontRef idx="minor">
+            <a:schemeClr val="lt1"/>
+          </a:fontRef>
+        </p:style>
+        <p:txBody>
+          <a:bodyPr rtlCol="0" anchor="ctr"/>
+          <a:lstStyle/>
+          <a:p>
+            <a:pPr algn="ctr"/>
+            <a:endParaRPr lang="en-US"/>
+          </a:p>
+        </p:txBody>
+      </p:sp>
+      <p:sp>
+        <p:nvSpPr>
+          <p:cNvPr id="8" name="Oval 7">
+            <a:extLst>
+              <a:ext uri="{FF2B5EF4-FFF2-40B4-BE49-F238E27FC236}">
+                <a16:creationId xmlns:a16="http://schemas.microsoft.com/office/drawing/2014/main" id="{C7B0B01F-9DD3-925F-62F5-3401FAD0DE5B}"/>
+              </a:ext>
+            </a:extLst>
+          </p:cNvPr>
+          <p:cNvSpPr/>
+          <p:nvPr/>
+        </p:nvSpPr>
+        <p:spPr>
+          <a:xfrm>
+            <a:off x="6393475" y="2174227"/>
+            <a:ext cx="457200" cy="457200"/>
+          </a:xfrm>
+          <a:prstGeom prst="ellipse">
+            <a:avLst/>
+          </a:prstGeom>
+          <a:solidFill>
+            <a:schemeClr val="bg1"/>
+          </a:solidFill>
+          <a:ln>
+            <a:solidFill>
+              <a:schemeClr val="tx1"/>
+            </a:solidFill>
+          </a:ln>
+        </p:spPr>
+        <p:style>
+          <a:lnRef idx="2">
+            <a:schemeClr val="accent1">
+              <a:shade val="15000"/>
+            </a:schemeClr>
+          </a:lnRef>
+          <a:fillRef idx="1">
+            <a:schemeClr val="accent1"/>
+          </a:fillRef>
+          <a:effectRef idx="0">
+            <a:schemeClr val="accent1"/>
+          </a:effectRef>
+          <a:fontRef idx="minor">
+            <a:schemeClr val="lt1"/>
+          </a:fontRef>
+        </p:style>
+        <p:txBody>
+          <a:bodyPr rtlCol="0" anchor="ctr"/>
+          <a:lstStyle/>
+          <a:p>
+            <a:pPr algn="ctr"/>
+            <a:endParaRPr lang="en-US"/>
+          </a:p>
+        </p:txBody>
+      </p:sp>
+      <p:sp>
+        <p:nvSpPr>
+          <p:cNvPr id="9" name="Oval 8">
+            <a:extLst>
+              <a:ext uri="{FF2B5EF4-FFF2-40B4-BE49-F238E27FC236}">
+                <a16:creationId xmlns:a16="http://schemas.microsoft.com/office/drawing/2014/main" id="{992EA040-1679-93EA-FC55-5433F1E0A148}"/>
+              </a:ext>
+            </a:extLst>
+          </p:cNvPr>
+          <p:cNvSpPr/>
+          <p:nvPr/>
+        </p:nvSpPr>
+        <p:spPr>
+          <a:xfrm>
+            <a:off x="4597806" y="3082001"/>
+            <a:ext cx="457200" cy="457200"/>
+          </a:xfrm>
+          <a:prstGeom prst="ellipse">
+            <a:avLst/>
+          </a:prstGeom>
+          <a:solidFill>
+            <a:schemeClr val="bg1"/>
+          </a:solidFill>
+          <a:ln>
+            <a:solidFill>
+              <a:schemeClr val="tx1"/>
+            </a:solidFill>
+          </a:ln>
+        </p:spPr>
+        <p:style>
+          <a:lnRef idx="2">
+            <a:schemeClr val="accent1">
+              <a:shade val="15000"/>
+            </a:schemeClr>
+          </a:lnRef>
+          <a:fillRef idx="1">
+            <a:schemeClr val="accent1"/>
+          </a:fillRef>
+          <a:effectRef idx="0">
+            <a:schemeClr val="accent1"/>
+          </a:effectRef>
+          <a:fontRef idx="minor">
+            <a:schemeClr val="lt1"/>
+          </a:fontRef>
+        </p:style>
+        <p:txBody>
+          <a:bodyPr rtlCol="0" anchor="ctr"/>
+          <a:lstStyle/>
+          <a:p>
+            <a:pPr algn="ctr"/>
+            <a:endParaRPr lang="en-US"/>
+          </a:p>
+        </p:txBody>
+      </p:sp>
+      <p:cxnSp>
+        <p:nvCxnSpPr>
+          <p:cNvPr id="11" name="Straight Connector 10">
+            <a:extLst>
+              <a:ext uri="{FF2B5EF4-FFF2-40B4-BE49-F238E27FC236}">
+                <a16:creationId xmlns:a16="http://schemas.microsoft.com/office/drawing/2014/main" id="{51488E0F-6689-0075-88A9-9AF1E42DC410}"/>
+              </a:ext>
+            </a:extLst>
+          </p:cNvPr>
+          <p:cNvCxnSpPr>
+            <a:cxnSpLocks/>
+            <a:stCxn id="9" idx="6"/>
+            <a:endCxn id="20" idx="3"/>
+          </p:cNvCxnSpPr>
+          <p:nvPr/>
+        </p:nvCxnSpPr>
+        <p:spPr>
+          <a:xfrm flipV="1">
+            <a:off x="5055006" y="2929323"/>
+            <a:ext cx="621987" cy="381278"/>
+          </a:xfrm>
+          <a:prstGeom prst="line">
+            <a:avLst/>
+          </a:prstGeom>
+          <a:ln w="57150">
+            <a:solidFill>
+              <a:schemeClr val="tx1"/>
+            </a:solidFill>
+          </a:ln>
+        </p:spPr>
+        <p:style>
+          <a:lnRef idx="2">
+            <a:schemeClr val="accent1"/>
+          </a:lnRef>
+          <a:fillRef idx="0">
+            <a:schemeClr val="accent1"/>
+          </a:fillRef>
+          <a:effectRef idx="1">
+            <a:schemeClr val="accent1"/>
+          </a:effectRef>
+          <a:fontRef idx="minor">
+            <a:schemeClr val="tx1"/>
+          </a:fontRef>
+        </p:style>
+      </p:cxnSp>
+      <p:cxnSp>
+        <p:nvCxnSpPr>
+          <p:cNvPr id="13" name="Straight Connector 12">
+            <a:extLst>
+              <a:ext uri="{FF2B5EF4-FFF2-40B4-BE49-F238E27FC236}">
+                <a16:creationId xmlns:a16="http://schemas.microsoft.com/office/drawing/2014/main" id="{2E5E57A1-F26A-AB93-F8EC-94350918AC96}"/>
+              </a:ext>
+            </a:extLst>
+          </p:cNvPr>
+          <p:cNvCxnSpPr>
+            <a:cxnSpLocks/>
+            <a:stCxn id="20" idx="7"/>
+            <a:endCxn id="8" idx="2"/>
+          </p:cNvCxnSpPr>
+          <p:nvPr/>
+        </p:nvCxnSpPr>
+        <p:spPr>
+          <a:xfrm flipV="1">
+            <a:off x="5806309" y="2402827"/>
+            <a:ext cx="587166" cy="397180"/>
+          </a:xfrm>
+          <a:prstGeom prst="line">
+            <a:avLst/>
+          </a:prstGeom>
+          <a:ln w="57150">
+            <a:solidFill>
+              <a:schemeClr val="tx1"/>
+            </a:solidFill>
+          </a:ln>
+        </p:spPr>
+        <p:style>
+          <a:lnRef idx="2">
+            <a:schemeClr val="accent1"/>
+          </a:lnRef>
+          <a:fillRef idx="0">
+            <a:schemeClr val="accent1"/>
+          </a:fillRef>
+          <a:effectRef idx="1">
+            <a:schemeClr val="accent1"/>
+          </a:effectRef>
+          <a:fontRef idx="minor">
+            <a:schemeClr val="tx1"/>
+          </a:fontRef>
+        </p:style>
+      </p:cxnSp>
+      <p:sp>
+        <p:nvSpPr>
+          <p:cNvPr id="20" name="Oval 19">
+            <a:extLst>
+              <a:ext uri="{FF2B5EF4-FFF2-40B4-BE49-F238E27FC236}">
+                <a16:creationId xmlns:a16="http://schemas.microsoft.com/office/drawing/2014/main" id="{789A596E-AE63-5B09-40CB-782E67704AEB}"/>
+              </a:ext>
+            </a:extLst>
+          </p:cNvPr>
+          <p:cNvSpPr/>
+          <p:nvPr/>
+        </p:nvSpPr>
+        <p:spPr>
+          <a:xfrm>
+            <a:off x="5650211" y="2773225"/>
+            <a:ext cx="182880" cy="182880"/>
+          </a:xfrm>
+          <a:prstGeom prst="ellipse">
+            <a:avLst/>
+          </a:prstGeom>
+          <a:noFill/>
+          <a:ln>
+            <a:solidFill>
+              <a:schemeClr val="tx1"/>
+            </a:solidFill>
+          </a:ln>
+        </p:spPr>
+        <p:style>
+          <a:lnRef idx="2">
+            <a:schemeClr val="accent1">
+              <a:shade val="15000"/>
+            </a:schemeClr>
+          </a:lnRef>
+          <a:fillRef idx="1">
+            <a:schemeClr val="accent1"/>
+          </a:fillRef>
+          <a:effectRef idx="0">
+            <a:schemeClr val="accent1"/>
+          </a:effectRef>
+          <a:fontRef idx="minor">
+            <a:schemeClr val="lt1"/>
+          </a:fontRef>
+        </p:style>
+        <p:txBody>
+          <a:bodyPr rtlCol="0" anchor="ctr"/>
+          <a:lstStyle/>
+          <a:p>
+            <a:pPr algn="ctr"/>
+            <a:endParaRPr lang="en-US"/>
+          </a:p>
+        </p:txBody>
+      </p:sp>
+      <p:sp>
+        <p:nvSpPr>
+          <p:cNvPr id="23" name="Oval 22">
+            <a:extLst>
+              <a:ext uri="{FF2B5EF4-FFF2-40B4-BE49-F238E27FC236}">
+                <a16:creationId xmlns:a16="http://schemas.microsoft.com/office/drawing/2014/main" id="{EBFD6DB5-EE93-6223-ADAF-2FDBEAF1C489}"/>
+              </a:ext>
+            </a:extLst>
+          </p:cNvPr>
+          <p:cNvSpPr/>
+          <p:nvPr/>
+        </p:nvSpPr>
+        <p:spPr>
+          <a:xfrm>
+            <a:off x="3834663" y="3671059"/>
+            <a:ext cx="182880" cy="182880"/>
+          </a:xfrm>
+          <a:prstGeom prst="ellipse">
+            <a:avLst/>
+          </a:prstGeom>
+          <a:noFill/>
+          <a:ln>
+            <a:solidFill>
+              <a:schemeClr val="tx1"/>
+            </a:solidFill>
+          </a:ln>
+        </p:spPr>
+        <p:style>
+          <a:lnRef idx="2">
+            <a:schemeClr val="accent1">
+              <a:shade val="15000"/>
+            </a:schemeClr>
+          </a:lnRef>
+          <a:fillRef idx="1">
+            <a:schemeClr val="accent1"/>
+          </a:fillRef>
+          <a:effectRef idx="0">
+            <a:schemeClr val="accent1"/>
+          </a:effectRef>
+          <a:fontRef idx="minor">
+            <a:schemeClr val="lt1"/>
+          </a:fontRef>
+        </p:style>
+        <p:txBody>
+          <a:bodyPr rtlCol="0" anchor="ctr"/>
+          <a:lstStyle/>
+          <a:p>
+            <a:pPr algn="ctr"/>
+            <a:endParaRPr lang="en-US"/>
+          </a:p>
+        </p:txBody>
+      </p:sp>
+      <p:sp>
+        <p:nvSpPr>
+          <p:cNvPr id="25" name="Oval 24">
+            <a:extLst>
+              <a:ext uri="{FF2B5EF4-FFF2-40B4-BE49-F238E27FC236}">
+                <a16:creationId xmlns:a16="http://schemas.microsoft.com/office/drawing/2014/main" id="{FC5D9AC0-0ACB-B510-E76F-937A1E1B73F0}"/>
+              </a:ext>
+            </a:extLst>
+          </p:cNvPr>
+          <p:cNvSpPr/>
+          <p:nvPr/>
+        </p:nvSpPr>
+        <p:spPr>
+          <a:xfrm>
+            <a:off x="7441463" y="1880359"/>
+            <a:ext cx="182880" cy="182880"/>
+          </a:xfrm>
+          <a:prstGeom prst="ellipse">
+            <a:avLst/>
+          </a:prstGeom>
+          <a:noFill/>
+          <a:ln>
+            <a:solidFill>
+              <a:schemeClr val="tx1"/>
+            </a:solidFill>
+          </a:ln>
+        </p:spPr>
+        <p:style>
+          <a:lnRef idx="2">
+            <a:schemeClr val="accent1">
+              <a:shade val="15000"/>
+            </a:schemeClr>
+          </a:lnRef>
+          <a:fillRef idx="1">
+            <a:schemeClr val="accent1"/>
+          </a:fillRef>
+          <a:effectRef idx="0">
+            <a:schemeClr val="accent1"/>
+          </a:effectRef>
+          <a:fontRef idx="minor">
+            <a:schemeClr val="lt1"/>
+          </a:fontRef>
+        </p:style>
+        <p:txBody>
+          <a:bodyPr rtlCol="0" anchor="ctr"/>
+          <a:lstStyle/>
+          <a:p>
+            <a:pPr algn="ctr"/>
+            <a:endParaRPr lang="en-US"/>
+          </a:p>
+        </p:txBody>
+      </p:sp>
+      <p:sp>
+        <p:nvSpPr>
+          <p:cNvPr id="26" name="Oval 25">
+            <a:extLst>
+              <a:ext uri="{FF2B5EF4-FFF2-40B4-BE49-F238E27FC236}">
+                <a16:creationId xmlns:a16="http://schemas.microsoft.com/office/drawing/2014/main" id="{52BEE2A5-D6F5-8859-906D-ED2D4E4B9916}"/>
+              </a:ext>
+            </a:extLst>
+          </p:cNvPr>
+          <p:cNvSpPr/>
+          <p:nvPr/>
+        </p:nvSpPr>
+        <p:spPr>
+          <a:xfrm>
+            <a:off x="8355863" y="1416809"/>
+            <a:ext cx="182880" cy="182880"/>
+          </a:xfrm>
+          <a:prstGeom prst="ellipse">
+            <a:avLst/>
+          </a:prstGeom>
+          <a:noFill/>
+          <a:ln>
+            <a:solidFill>
+              <a:schemeClr val="tx1"/>
+            </a:solidFill>
+          </a:ln>
+        </p:spPr>
+        <p:style>
+          <a:lnRef idx="2">
+            <a:schemeClr val="accent1">
+              <a:shade val="15000"/>
+            </a:schemeClr>
+          </a:lnRef>
+          <a:fillRef idx="1">
+            <a:schemeClr val="accent1"/>
+          </a:fillRef>
+          <a:effectRef idx="0">
+            <a:schemeClr val="accent1"/>
+          </a:effectRef>
+          <a:fontRef idx="minor">
+            <a:schemeClr val="lt1"/>
+          </a:fontRef>
+        </p:style>
+        <p:txBody>
+          <a:bodyPr rtlCol="0" anchor="ctr"/>
+          <a:lstStyle/>
+          <a:p>
+            <a:pPr algn="ctr"/>
+            <a:endParaRPr lang="en-US"/>
+          </a:p>
+        </p:txBody>
+      </p:sp>
+      <p:cxnSp>
+        <p:nvCxnSpPr>
+          <p:cNvPr id="31" name="Straight Connector 30">
+            <a:extLst>
+              <a:ext uri="{FF2B5EF4-FFF2-40B4-BE49-F238E27FC236}">
+                <a16:creationId xmlns:a16="http://schemas.microsoft.com/office/drawing/2014/main" id="{E026FBF4-4539-4F29-6FFB-F5794EA79E02}"/>
+              </a:ext>
+            </a:extLst>
+          </p:cNvPr>
+          <p:cNvCxnSpPr>
+            <a:cxnSpLocks/>
+            <a:stCxn id="8" idx="6"/>
+            <a:endCxn id="25" idx="3"/>
+          </p:cNvCxnSpPr>
+          <p:nvPr/>
+        </p:nvCxnSpPr>
+        <p:spPr>
+          <a:xfrm flipV="1">
+            <a:off x="6850675" y="2036457"/>
+            <a:ext cx="617570" cy="366370"/>
+          </a:xfrm>
+          <a:prstGeom prst="line">
+            <a:avLst/>
+          </a:prstGeom>
+          <a:ln w="57150">
+            <a:solidFill>
+              <a:schemeClr val="tx1"/>
+            </a:solidFill>
+            <a:prstDash val="dash"/>
+          </a:ln>
+        </p:spPr>
+        <p:style>
+          <a:lnRef idx="2">
+            <a:schemeClr val="accent1"/>
+          </a:lnRef>
+          <a:fillRef idx="0">
+            <a:schemeClr val="accent1"/>
+          </a:fillRef>
+          <a:effectRef idx="1">
+            <a:schemeClr val="accent1"/>
+          </a:effectRef>
+          <a:fontRef idx="minor">
+            <a:schemeClr val="tx1"/>
+          </a:fontRef>
+        </p:style>
+      </p:cxnSp>
+      <p:cxnSp>
+        <p:nvCxnSpPr>
+          <p:cNvPr id="34" name="Straight Connector 33">
+            <a:extLst>
+              <a:ext uri="{FF2B5EF4-FFF2-40B4-BE49-F238E27FC236}">
+                <a16:creationId xmlns:a16="http://schemas.microsoft.com/office/drawing/2014/main" id="{084FE08A-6526-DEA9-2382-3CD09DDB8A46}"/>
+              </a:ext>
+            </a:extLst>
+          </p:cNvPr>
+          <p:cNvCxnSpPr>
+            <a:cxnSpLocks/>
+            <a:stCxn id="25" idx="7"/>
+            <a:endCxn id="26" idx="3"/>
+          </p:cNvCxnSpPr>
+          <p:nvPr/>
+        </p:nvCxnSpPr>
+        <p:spPr>
+          <a:xfrm flipV="1">
+            <a:off x="7597561" y="1572907"/>
+            <a:ext cx="785084" cy="334234"/>
+          </a:xfrm>
+          <a:prstGeom prst="line">
+            <a:avLst/>
+          </a:prstGeom>
+          <a:ln w="57150">
+            <a:solidFill>
+              <a:schemeClr val="tx1"/>
+            </a:solidFill>
+            <a:prstDash val="dash"/>
+          </a:ln>
+        </p:spPr>
+        <p:style>
+          <a:lnRef idx="2">
+            <a:schemeClr val="accent1"/>
+          </a:lnRef>
+          <a:fillRef idx="0">
+            <a:schemeClr val="accent1"/>
+          </a:fillRef>
+          <a:effectRef idx="1">
+            <a:schemeClr val="accent1"/>
+          </a:effectRef>
+          <a:fontRef idx="minor">
+            <a:schemeClr val="tx1"/>
+          </a:fontRef>
+        </p:style>
+      </p:cxnSp>
+      <p:cxnSp>
+        <p:nvCxnSpPr>
+          <p:cNvPr id="37" name="Straight Connector 36">
+            <a:extLst>
+              <a:ext uri="{FF2B5EF4-FFF2-40B4-BE49-F238E27FC236}">
+                <a16:creationId xmlns:a16="http://schemas.microsoft.com/office/drawing/2014/main" id="{49FF188E-AD4E-23D3-0BB3-3FE18320003F}"/>
+              </a:ext>
+            </a:extLst>
+          </p:cNvPr>
+          <p:cNvCxnSpPr>
+            <a:cxnSpLocks/>
+            <a:stCxn id="26" idx="5"/>
+            <a:endCxn id="5" idx="1"/>
+          </p:cNvCxnSpPr>
+          <p:nvPr/>
+        </p:nvCxnSpPr>
+        <p:spPr>
+          <a:xfrm>
+            <a:off x="8511961" y="1572907"/>
+            <a:ext cx="1314104" cy="1449736"/>
+          </a:xfrm>
+          <a:prstGeom prst="line">
+            <a:avLst/>
+          </a:prstGeom>
+          <a:ln w="57150">
+            <a:solidFill>
+              <a:schemeClr val="tx1"/>
+            </a:solidFill>
+            <a:prstDash val="dash"/>
+          </a:ln>
+        </p:spPr>
+        <p:style>
+          <a:lnRef idx="2">
+            <a:schemeClr val="accent1"/>
+          </a:lnRef>
+          <a:fillRef idx="0">
+            <a:schemeClr val="accent1"/>
+          </a:fillRef>
+          <a:effectRef idx="1">
+            <a:schemeClr val="accent1"/>
+          </a:effectRef>
+          <a:fontRef idx="minor">
+            <a:schemeClr val="tx1"/>
+          </a:fontRef>
+        </p:style>
+      </p:cxnSp>
+      <p:cxnSp>
+        <p:nvCxnSpPr>
+          <p:cNvPr id="41" name="Straight Connector 40">
+            <a:extLst>
+              <a:ext uri="{FF2B5EF4-FFF2-40B4-BE49-F238E27FC236}">
+                <a16:creationId xmlns:a16="http://schemas.microsoft.com/office/drawing/2014/main" id="{B9669FEF-E444-80BE-F37F-D2E7993809CB}"/>
+              </a:ext>
+            </a:extLst>
+          </p:cNvPr>
+          <p:cNvCxnSpPr>
+            <a:cxnSpLocks/>
+            <a:stCxn id="23" idx="7"/>
+            <a:endCxn id="9" idx="2"/>
+          </p:cNvCxnSpPr>
+          <p:nvPr/>
+        </p:nvCxnSpPr>
+        <p:spPr>
+          <a:xfrm flipV="1">
+            <a:off x="3990761" y="3310601"/>
+            <a:ext cx="607045" cy="387240"/>
+          </a:xfrm>
+          <a:prstGeom prst="line">
+            <a:avLst/>
+          </a:prstGeom>
+          <a:ln w="57150">
+            <a:solidFill>
+              <a:schemeClr val="tx1"/>
+            </a:solidFill>
+            <a:prstDash val="dash"/>
+          </a:ln>
+        </p:spPr>
+        <p:style>
+          <a:lnRef idx="2">
+            <a:schemeClr val="accent1"/>
+          </a:lnRef>
+          <a:fillRef idx="0">
+            <a:schemeClr val="accent1"/>
+          </a:fillRef>
+          <a:effectRef idx="1">
+            <a:schemeClr val="accent1"/>
+          </a:effectRef>
+          <a:fontRef idx="minor">
+            <a:schemeClr val="tx1"/>
+          </a:fontRef>
+        </p:style>
+      </p:cxnSp>
+      <p:cxnSp>
+        <p:nvCxnSpPr>
+          <p:cNvPr id="44" name="Straight Connector 43">
+            <a:extLst>
+              <a:ext uri="{FF2B5EF4-FFF2-40B4-BE49-F238E27FC236}">
+                <a16:creationId xmlns:a16="http://schemas.microsoft.com/office/drawing/2014/main" id="{6C543D06-EFE3-23EA-7F23-1F6F416527F0}"/>
+              </a:ext>
+            </a:extLst>
+          </p:cNvPr>
+          <p:cNvCxnSpPr>
+            <a:cxnSpLocks/>
+            <a:stCxn id="23" idx="2"/>
+            <a:endCxn id="4" idx="5"/>
+          </p:cNvCxnSpPr>
+          <p:nvPr/>
+        </p:nvCxnSpPr>
+        <p:spPr>
+          <a:xfrm flipH="1" flipV="1">
+            <a:off x="2528495" y="3151961"/>
+            <a:ext cx="1306168" cy="610538"/>
+          </a:xfrm>
+          <a:prstGeom prst="line">
+            <a:avLst/>
+          </a:prstGeom>
+          <a:ln w="57150">
+            <a:solidFill>
+              <a:schemeClr val="tx1"/>
+            </a:solidFill>
+            <a:prstDash val="dash"/>
+          </a:ln>
+        </p:spPr>
+        <p:style>
+          <a:lnRef idx="2">
+            <a:schemeClr val="accent1"/>
+          </a:lnRef>
+          <a:fillRef idx="0">
+            <a:schemeClr val="accent1"/>
+          </a:fillRef>
+          <a:effectRef idx="1">
+            <a:schemeClr val="accent1"/>
+          </a:effectRef>
+          <a:fontRef idx="minor">
+            <a:schemeClr val="tx1"/>
+          </a:fontRef>
+        </p:style>
+      </p:cxnSp>
+    </p:spTree>
+    <p:extLst>
+      <p:ext uri="{BB962C8B-B14F-4D97-AF65-F5344CB8AC3E}">
+        <p14:creationId xmlns:p14="http://schemas.microsoft.com/office/powerpoint/2010/main" val="1726148638"/>
+      </p:ext>
+    </p:extLst>
+  </p:cSld>
+  <p:clrMapOvr>
+    <a:masterClrMapping/>
+  </p:clrMapOvr>
+</p:sld>
+</file>
+
+<file path=ppt/slides/slide24.xml><?xml version="1.0" encoding="utf-8"?>
+<p:sld xmlns:a="http://schemas.openxmlformats.org/drawingml/2006/main" xmlns:r="http://schemas.openxmlformats.org/officeDocument/2006/relationships" xmlns:p="http://schemas.openxmlformats.org/presentationml/2006/main">
+  <p:cSld>
+    <p:spTree>
+      <p:nvGrpSpPr>
+        <p:cNvPr id="1" name="">
+          <a:extLst>
+            <a:ext uri="{FF2B5EF4-FFF2-40B4-BE49-F238E27FC236}">
+              <a16:creationId xmlns:a16="http://schemas.microsoft.com/office/drawing/2014/main" id="{DCA82A4E-D722-DBBE-E71D-BC1C8E23BFE7}"/>
+            </a:ext>
+          </a:extLst>
+        </p:cNvPr>
+        <p:cNvGrpSpPr/>
+        <p:nvPr/>
+      </p:nvGrpSpPr>
+      <p:grpSpPr>
+        <a:xfrm>
+          <a:off x="0" y="0"/>
+          <a:ext cx="0" cy="0"/>
+          <a:chOff x="0" y="0"/>
+          <a:chExt cx="0" cy="0"/>
+        </a:xfrm>
+      </p:grpSpPr>
+      <p:pic>
+        <p:nvPicPr>
+          <p:cNvPr id="3" name="Graphic 2">
+            <a:extLst>
+              <a:ext uri="{FF2B5EF4-FFF2-40B4-BE49-F238E27FC236}">
+                <a16:creationId xmlns:a16="http://schemas.microsoft.com/office/drawing/2014/main" id="{1501A402-F6D8-8AFE-908B-1A57D9416B9A}"/>
+              </a:ext>
+            </a:extLst>
+          </p:cNvPr>
+          <p:cNvPicPr>
+            <a:picLocks noChangeAspect="1"/>
+          </p:cNvPicPr>
+          <p:nvPr/>
+        </p:nvPicPr>
+        <p:blipFill>
+          <a:blip>
+            <a:extLst>
+              <a:ext uri="{96DAC541-7B7A-43D3-8B79-37D633B846F1}">
+                <asvg:svgBlip xmlns:asvg="http://schemas.microsoft.com/office/drawing/2016/SVG/main" r:embed="rId2"/>
+              </a:ext>
+            </a:extLst>
+          </a:blip>
+          <a:srcRect r="12222" b="12456"/>
+          <a:stretch>
+            <a:fillRect/>
+          </a:stretch>
+        </p:blipFill>
+        <p:spPr>
+          <a:xfrm>
+            <a:off x="3086100" y="222583"/>
+            <a:ext cx="6019800" cy="6003757"/>
+          </a:xfrm>
+          <a:prstGeom prst="rect">
+            <a:avLst/>
+          </a:prstGeom>
+        </p:spPr>
+      </p:pic>
+      <p:sp>
+        <p:nvSpPr>
+          <p:cNvPr id="4" name="Oval 3">
+            <a:extLst>
+              <a:ext uri="{FF2B5EF4-FFF2-40B4-BE49-F238E27FC236}">
+                <a16:creationId xmlns:a16="http://schemas.microsoft.com/office/drawing/2014/main" id="{78A52DD9-D4B5-527A-7C28-EDD97AF2216C}"/>
+              </a:ext>
+            </a:extLst>
+          </p:cNvPr>
+          <p:cNvSpPr/>
+          <p:nvPr/>
+        </p:nvSpPr>
+        <p:spPr>
+          <a:xfrm>
+            <a:off x="2372397" y="2995863"/>
+            <a:ext cx="182880" cy="182880"/>
+          </a:xfrm>
+          <a:prstGeom prst="ellipse">
+            <a:avLst/>
+          </a:prstGeom>
+          <a:solidFill>
+            <a:srgbClr val="FFFF00"/>
+          </a:solidFill>
+          <a:ln>
+            <a:solidFill>
+              <a:schemeClr val="tx1"/>
+            </a:solidFill>
+          </a:ln>
+        </p:spPr>
+        <p:style>
+          <a:lnRef idx="2">
+            <a:schemeClr val="accent1">
+              <a:shade val="15000"/>
+            </a:schemeClr>
+          </a:lnRef>
+          <a:fillRef idx="1">
+            <a:schemeClr val="accent1"/>
+          </a:fillRef>
+          <a:effectRef idx="0">
+            <a:schemeClr val="accent1"/>
+          </a:effectRef>
+          <a:fontRef idx="minor">
+            <a:schemeClr val="lt1"/>
+          </a:fontRef>
+        </p:style>
+        <p:txBody>
+          <a:bodyPr rtlCol="0" anchor="ctr"/>
+          <a:lstStyle/>
+          <a:p>
+            <a:pPr algn="ctr"/>
+            <a:endParaRPr lang="en-US"/>
+          </a:p>
+        </p:txBody>
+      </p:sp>
+      <p:sp>
+        <p:nvSpPr>
+          <p:cNvPr id="5" name="Oval 4">
+            <a:extLst>
+              <a:ext uri="{FF2B5EF4-FFF2-40B4-BE49-F238E27FC236}">
+                <a16:creationId xmlns:a16="http://schemas.microsoft.com/office/drawing/2014/main" id="{C3DE037D-C2C6-96CD-C666-B8FECF56F867}"/>
+              </a:ext>
+            </a:extLst>
+          </p:cNvPr>
+          <p:cNvSpPr/>
+          <p:nvPr/>
+        </p:nvSpPr>
+        <p:spPr>
+          <a:xfrm>
+            <a:off x="9799283" y="2995861"/>
+            <a:ext cx="182880" cy="182880"/>
+          </a:xfrm>
+          <a:prstGeom prst="ellipse">
+            <a:avLst/>
+          </a:prstGeom>
+          <a:solidFill>
+            <a:srgbClr val="FFFF00"/>
+          </a:solidFill>
+          <a:ln>
+            <a:solidFill>
+              <a:schemeClr val="tx1"/>
+            </a:solidFill>
+          </a:ln>
+        </p:spPr>
+        <p:style>
+          <a:lnRef idx="2">
+            <a:schemeClr val="accent1">
+              <a:shade val="15000"/>
+            </a:schemeClr>
+          </a:lnRef>
+          <a:fillRef idx="1">
+            <a:schemeClr val="accent1"/>
+          </a:fillRef>
+          <a:effectRef idx="0">
+            <a:schemeClr val="accent1"/>
+          </a:effectRef>
+          <a:fontRef idx="minor">
+            <a:schemeClr val="lt1"/>
+          </a:fontRef>
+        </p:style>
+        <p:txBody>
+          <a:bodyPr rtlCol="0" anchor="ctr"/>
+          <a:lstStyle/>
+          <a:p>
+            <a:pPr algn="ctr"/>
+            <a:endParaRPr lang="en-US"/>
+          </a:p>
+        </p:txBody>
+      </p:sp>
+      <p:sp>
+        <p:nvSpPr>
+          <p:cNvPr id="8" name="Oval 7">
+            <a:extLst>
+              <a:ext uri="{FF2B5EF4-FFF2-40B4-BE49-F238E27FC236}">
+                <a16:creationId xmlns:a16="http://schemas.microsoft.com/office/drawing/2014/main" id="{22FBD542-3A16-ACAE-7AFC-C5DD268FDD51}"/>
+              </a:ext>
+            </a:extLst>
+          </p:cNvPr>
+          <p:cNvSpPr/>
+          <p:nvPr/>
+        </p:nvSpPr>
+        <p:spPr>
+          <a:xfrm>
+            <a:off x="6393475" y="2174227"/>
+            <a:ext cx="457200" cy="457200"/>
+          </a:xfrm>
+          <a:prstGeom prst="ellipse">
+            <a:avLst/>
+          </a:prstGeom>
+          <a:solidFill>
+            <a:schemeClr val="bg1"/>
+          </a:solidFill>
+          <a:ln>
+            <a:solidFill>
+              <a:schemeClr val="tx1"/>
+            </a:solidFill>
+          </a:ln>
+        </p:spPr>
+        <p:style>
+          <a:lnRef idx="2">
+            <a:schemeClr val="accent1">
+              <a:shade val="15000"/>
+            </a:schemeClr>
+          </a:lnRef>
+          <a:fillRef idx="1">
+            <a:schemeClr val="accent1"/>
+          </a:fillRef>
+          <a:effectRef idx="0">
+            <a:schemeClr val="accent1"/>
+          </a:effectRef>
+          <a:fontRef idx="minor">
+            <a:schemeClr val="lt1"/>
+          </a:fontRef>
+        </p:style>
+        <p:txBody>
+          <a:bodyPr rtlCol="0" anchor="ctr"/>
+          <a:lstStyle/>
+          <a:p>
+            <a:pPr algn="ctr"/>
+            <a:endParaRPr lang="en-US"/>
+          </a:p>
+        </p:txBody>
+      </p:sp>
+      <p:sp>
+        <p:nvSpPr>
+          <p:cNvPr id="9" name="Oval 8">
+            <a:extLst>
+              <a:ext uri="{FF2B5EF4-FFF2-40B4-BE49-F238E27FC236}">
+                <a16:creationId xmlns:a16="http://schemas.microsoft.com/office/drawing/2014/main" id="{9E92F7F6-887F-0F4A-5458-FC303F8FD84E}"/>
+              </a:ext>
+            </a:extLst>
+          </p:cNvPr>
+          <p:cNvSpPr/>
+          <p:nvPr/>
+        </p:nvSpPr>
+        <p:spPr>
+          <a:xfrm>
+            <a:off x="4597806" y="3082001"/>
+            <a:ext cx="457200" cy="457200"/>
+          </a:xfrm>
+          <a:prstGeom prst="ellipse">
+            <a:avLst/>
+          </a:prstGeom>
+          <a:solidFill>
+            <a:schemeClr val="bg1"/>
+          </a:solidFill>
+          <a:ln>
+            <a:solidFill>
+              <a:schemeClr val="tx1"/>
+            </a:solidFill>
+          </a:ln>
+        </p:spPr>
+        <p:style>
+          <a:lnRef idx="2">
+            <a:schemeClr val="accent1">
+              <a:shade val="15000"/>
+            </a:schemeClr>
+          </a:lnRef>
+          <a:fillRef idx="1">
+            <a:schemeClr val="accent1"/>
+          </a:fillRef>
+          <a:effectRef idx="0">
+            <a:schemeClr val="accent1"/>
+          </a:effectRef>
+          <a:fontRef idx="minor">
+            <a:schemeClr val="lt1"/>
+          </a:fontRef>
+        </p:style>
+        <p:txBody>
+          <a:bodyPr rtlCol="0" anchor="ctr"/>
+          <a:lstStyle/>
+          <a:p>
+            <a:pPr algn="ctr"/>
+            <a:endParaRPr lang="en-US"/>
+          </a:p>
+        </p:txBody>
+      </p:sp>
+      <p:cxnSp>
+        <p:nvCxnSpPr>
+          <p:cNvPr id="11" name="Straight Connector 10">
+            <a:extLst>
+              <a:ext uri="{FF2B5EF4-FFF2-40B4-BE49-F238E27FC236}">
+                <a16:creationId xmlns:a16="http://schemas.microsoft.com/office/drawing/2014/main" id="{B993B9A9-B220-83FB-7A05-2545FE79E7EC}"/>
+              </a:ext>
+            </a:extLst>
+          </p:cNvPr>
+          <p:cNvCxnSpPr>
+            <a:cxnSpLocks/>
+            <a:stCxn id="9" idx="6"/>
+            <a:endCxn id="20" idx="3"/>
+          </p:cNvCxnSpPr>
+          <p:nvPr/>
+        </p:nvCxnSpPr>
+        <p:spPr>
+          <a:xfrm flipV="1">
+            <a:off x="5055006" y="2929323"/>
+            <a:ext cx="621987" cy="381278"/>
+          </a:xfrm>
+          <a:prstGeom prst="line">
+            <a:avLst/>
+          </a:prstGeom>
+          <a:ln w="57150">
+            <a:solidFill>
+              <a:schemeClr val="tx1"/>
+            </a:solidFill>
+            <a:prstDash val="dash"/>
+          </a:ln>
+        </p:spPr>
+        <p:style>
+          <a:lnRef idx="2">
+            <a:schemeClr val="accent1"/>
+          </a:lnRef>
+          <a:fillRef idx="0">
+            <a:schemeClr val="accent1"/>
+          </a:fillRef>
+          <a:effectRef idx="1">
+            <a:schemeClr val="accent1"/>
+          </a:effectRef>
+          <a:fontRef idx="minor">
+            <a:schemeClr val="tx1"/>
+          </a:fontRef>
+        </p:style>
+      </p:cxnSp>
+      <p:cxnSp>
+        <p:nvCxnSpPr>
+          <p:cNvPr id="13" name="Straight Connector 12">
+            <a:extLst>
+              <a:ext uri="{FF2B5EF4-FFF2-40B4-BE49-F238E27FC236}">
+                <a16:creationId xmlns:a16="http://schemas.microsoft.com/office/drawing/2014/main" id="{B42671FA-D5CD-54A0-9AEC-4C7A839F6E8D}"/>
+              </a:ext>
+            </a:extLst>
+          </p:cNvPr>
+          <p:cNvCxnSpPr>
+            <a:cxnSpLocks/>
+            <a:stCxn id="20" idx="7"/>
+            <a:endCxn id="8" idx="2"/>
+          </p:cNvCxnSpPr>
+          <p:nvPr/>
+        </p:nvCxnSpPr>
+        <p:spPr>
+          <a:xfrm flipV="1">
+            <a:off x="5806309" y="2402827"/>
+            <a:ext cx="587166" cy="397180"/>
+          </a:xfrm>
+          <a:prstGeom prst="line">
+            <a:avLst/>
+          </a:prstGeom>
+          <a:ln w="57150">
+            <a:solidFill>
+              <a:schemeClr val="tx1"/>
+            </a:solidFill>
+            <a:prstDash val="dash"/>
+          </a:ln>
+        </p:spPr>
+        <p:style>
+          <a:lnRef idx="2">
+            <a:schemeClr val="accent1"/>
+          </a:lnRef>
+          <a:fillRef idx="0">
+            <a:schemeClr val="accent1"/>
+          </a:fillRef>
+          <a:effectRef idx="1">
+            <a:schemeClr val="accent1"/>
+          </a:effectRef>
+          <a:fontRef idx="minor">
+            <a:schemeClr val="tx1"/>
+          </a:fontRef>
+        </p:style>
+      </p:cxnSp>
+      <p:sp>
+        <p:nvSpPr>
+          <p:cNvPr id="20" name="Oval 19">
+            <a:extLst>
+              <a:ext uri="{FF2B5EF4-FFF2-40B4-BE49-F238E27FC236}">
+                <a16:creationId xmlns:a16="http://schemas.microsoft.com/office/drawing/2014/main" id="{E2F4B053-BE99-0E50-58F0-5459213A6051}"/>
+              </a:ext>
+            </a:extLst>
+          </p:cNvPr>
+          <p:cNvSpPr/>
+          <p:nvPr/>
+        </p:nvSpPr>
+        <p:spPr>
+          <a:xfrm>
+            <a:off x="5650211" y="2773225"/>
+            <a:ext cx="182880" cy="182880"/>
+          </a:xfrm>
+          <a:prstGeom prst="ellipse">
+            <a:avLst/>
+          </a:prstGeom>
+          <a:noFill/>
+          <a:ln>
+            <a:solidFill>
+              <a:schemeClr val="tx1"/>
+            </a:solidFill>
+          </a:ln>
+        </p:spPr>
+        <p:style>
+          <a:lnRef idx="2">
+            <a:schemeClr val="accent1">
+              <a:shade val="15000"/>
+            </a:schemeClr>
+          </a:lnRef>
+          <a:fillRef idx="1">
+            <a:schemeClr val="accent1"/>
+          </a:fillRef>
+          <a:effectRef idx="0">
+            <a:schemeClr val="accent1"/>
+          </a:effectRef>
+          <a:fontRef idx="minor">
+            <a:schemeClr val="lt1"/>
+          </a:fontRef>
+        </p:style>
+        <p:txBody>
+          <a:bodyPr rtlCol="0" anchor="ctr"/>
+          <a:lstStyle/>
+          <a:p>
+            <a:pPr algn="ctr"/>
+            <a:endParaRPr lang="en-US"/>
+          </a:p>
+        </p:txBody>
+      </p:sp>
+      <p:sp>
+        <p:nvSpPr>
+          <p:cNvPr id="23" name="Oval 22">
+            <a:extLst>
+              <a:ext uri="{FF2B5EF4-FFF2-40B4-BE49-F238E27FC236}">
+                <a16:creationId xmlns:a16="http://schemas.microsoft.com/office/drawing/2014/main" id="{D76969C3-C716-D297-5E60-B2DD28C988C2}"/>
+              </a:ext>
+            </a:extLst>
+          </p:cNvPr>
+          <p:cNvSpPr/>
+          <p:nvPr/>
+        </p:nvSpPr>
+        <p:spPr>
+          <a:xfrm>
+            <a:off x="3834663" y="3671059"/>
+            <a:ext cx="182880" cy="182880"/>
+          </a:xfrm>
+          <a:prstGeom prst="ellipse">
+            <a:avLst/>
+          </a:prstGeom>
+          <a:noFill/>
+          <a:ln>
+            <a:solidFill>
+              <a:schemeClr val="tx1"/>
+            </a:solidFill>
+          </a:ln>
+        </p:spPr>
+        <p:style>
+          <a:lnRef idx="2">
+            <a:schemeClr val="accent1">
+              <a:shade val="15000"/>
+            </a:schemeClr>
+          </a:lnRef>
+          <a:fillRef idx="1">
+            <a:schemeClr val="accent1"/>
+          </a:fillRef>
+          <a:effectRef idx="0">
+            <a:schemeClr val="accent1"/>
+          </a:effectRef>
+          <a:fontRef idx="minor">
+            <a:schemeClr val="lt1"/>
+          </a:fontRef>
+        </p:style>
+        <p:txBody>
+          <a:bodyPr rtlCol="0" anchor="ctr"/>
+          <a:lstStyle/>
+          <a:p>
+            <a:pPr algn="ctr"/>
+            <a:endParaRPr lang="en-US"/>
+          </a:p>
+        </p:txBody>
+      </p:sp>
+      <p:sp>
+        <p:nvSpPr>
+          <p:cNvPr id="25" name="Oval 24">
+            <a:extLst>
+              <a:ext uri="{FF2B5EF4-FFF2-40B4-BE49-F238E27FC236}">
+                <a16:creationId xmlns:a16="http://schemas.microsoft.com/office/drawing/2014/main" id="{0A4828FA-FAC4-A163-0A88-A8663A2D3872}"/>
+              </a:ext>
+            </a:extLst>
+          </p:cNvPr>
+          <p:cNvSpPr/>
+          <p:nvPr/>
+        </p:nvSpPr>
+        <p:spPr>
+          <a:xfrm>
+            <a:off x="7441463" y="1880359"/>
+            <a:ext cx="182880" cy="182880"/>
+          </a:xfrm>
+          <a:prstGeom prst="ellipse">
+            <a:avLst/>
+          </a:prstGeom>
+          <a:noFill/>
+          <a:ln>
+            <a:solidFill>
+              <a:schemeClr val="tx1"/>
+            </a:solidFill>
+          </a:ln>
+        </p:spPr>
+        <p:style>
+          <a:lnRef idx="2">
+            <a:schemeClr val="accent1">
+              <a:shade val="15000"/>
+            </a:schemeClr>
+          </a:lnRef>
+          <a:fillRef idx="1">
+            <a:schemeClr val="accent1"/>
+          </a:fillRef>
+          <a:effectRef idx="0">
+            <a:schemeClr val="accent1"/>
+          </a:effectRef>
+          <a:fontRef idx="minor">
+            <a:schemeClr val="lt1"/>
+          </a:fontRef>
+        </p:style>
+        <p:txBody>
+          <a:bodyPr rtlCol="0" anchor="ctr"/>
+          <a:lstStyle/>
+          <a:p>
+            <a:pPr algn="ctr"/>
+            <a:endParaRPr lang="en-US"/>
+          </a:p>
+        </p:txBody>
+      </p:sp>
+      <p:sp>
+        <p:nvSpPr>
+          <p:cNvPr id="26" name="Oval 25">
+            <a:extLst>
+              <a:ext uri="{FF2B5EF4-FFF2-40B4-BE49-F238E27FC236}">
+                <a16:creationId xmlns:a16="http://schemas.microsoft.com/office/drawing/2014/main" id="{AD390312-C193-C2C6-9EA2-0EE18389B265}"/>
+              </a:ext>
+            </a:extLst>
+          </p:cNvPr>
+          <p:cNvSpPr/>
+          <p:nvPr/>
+        </p:nvSpPr>
+        <p:spPr>
+          <a:xfrm>
+            <a:off x="8355863" y="1416809"/>
+            <a:ext cx="182880" cy="182880"/>
+          </a:xfrm>
+          <a:prstGeom prst="ellipse">
+            <a:avLst/>
+          </a:prstGeom>
+          <a:noFill/>
+          <a:ln>
+            <a:solidFill>
+              <a:schemeClr val="tx1"/>
+            </a:solidFill>
+          </a:ln>
+        </p:spPr>
+        <p:style>
+          <a:lnRef idx="2">
+            <a:schemeClr val="accent1">
+              <a:shade val="15000"/>
+            </a:schemeClr>
+          </a:lnRef>
+          <a:fillRef idx="1">
+            <a:schemeClr val="accent1"/>
+          </a:fillRef>
+          <a:effectRef idx="0">
+            <a:schemeClr val="accent1"/>
+          </a:effectRef>
+          <a:fontRef idx="minor">
+            <a:schemeClr val="lt1"/>
+          </a:fontRef>
+        </p:style>
+        <p:txBody>
+          <a:bodyPr rtlCol="0" anchor="ctr"/>
+          <a:lstStyle/>
+          <a:p>
+            <a:pPr algn="ctr"/>
+            <a:endParaRPr lang="en-US"/>
+          </a:p>
+        </p:txBody>
+      </p:sp>
+      <p:cxnSp>
+        <p:nvCxnSpPr>
+          <p:cNvPr id="31" name="Straight Connector 30">
+            <a:extLst>
+              <a:ext uri="{FF2B5EF4-FFF2-40B4-BE49-F238E27FC236}">
+                <a16:creationId xmlns:a16="http://schemas.microsoft.com/office/drawing/2014/main" id="{BD9BE005-6055-564D-1953-F43593D800F1}"/>
+              </a:ext>
+            </a:extLst>
+          </p:cNvPr>
+          <p:cNvCxnSpPr>
+            <a:cxnSpLocks/>
+            <a:stCxn id="8" idx="6"/>
+            <a:endCxn id="25" idx="3"/>
+          </p:cNvCxnSpPr>
+          <p:nvPr/>
+        </p:nvCxnSpPr>
+        <p:spPr>
+          <a:xfrm flipV="1">
+            <a:off x="6850675" y="2036457"/>
+            <a:ext cx="617570" cy="366370"/>
+          </a:xfrm>
+          <a:prstGeom prst="line">
+            <a:avLst/>
+          </a:prstGeom>
+          <a:ln w="57150">
+            <a:solidFill>
+              <a:schemeClr val="tx1"/>
+            </a:solidFill>
+            <a:prstDash val="solid"/>
+          </a:ln>
+        </p:spPr>
+        <p:style>
+          <a:lnRef idx="2">
+            <a:schemeClr val="accent1"/>
+          </a:lnRef>
+          <a:fillRef idx="0">
+            <a:schemeClr val="accent1"/>
+          </a:fillRef>
+          <a:effectRef idx="1">
+            <a:schemeClr val="accent1"/>
+          </a:effectRef>
+          <a:fontRef idx="minor">
+            <a:schemeClr val="tx1"/>
+          </a:fontRef>
+        </p:style>
+      </p:cxnSp>
+      <p:cxnSp>
+        <p:nvCxnSpPr>
+          <p:cNvPr id="34" name="Straight Connector 33">
+            <a:extLst>
+              <a:ext uri="{FF2B5EF4-FFF2-40B4-BE49-F238E27FC236}">
+                <a16:creationId xmlns:a16="http://schemas.microsoft.com/office/drawing/2014/main" id="{713FF6BE-7F1E-88C6-7116-258E2835FB85}"/>
+              </a:ext>
+            </a:extLst>
+          </p:cNvPr>
+          <p:cNvCxnSpPr>
+            <a:cxnSpLocks/>
+            <a:stCxn id="25" idx="7"/>
+            <a:endCxn id="26" idx="3"/>
+          </p:cNvCxnSpPr>
+          <p:nvPr/>
+        </p:nvCxnSpPr>
+        <p:spPr>
+          <a:xfrm flipV="1">
+            <a:off x="7597561" y="1572907"/>
+            <a:ext cx="785084" cy="334234"/>
+          </a:xfrm>
+          <a:prstGeom prst="line">
+            <a:avLst/>
+          </a:prstGeom>
+          <a:ln w="57150">
+            <a:solidFill>
+              <a:schemeClr val="tx1"/>
+            </a:solidFill>
+            <a:prstDash val="solid"/>
+          </a:ln>
+        </p:spPr>
+        <p:style>
+          <a:lnRef idx="2">
+            <a:schemeClr val="accent1"/>
+          </a:lnRef>
+          <a:fillRef idx="0">
+            <a:schemeClr val="accent1"/>
+          </a:fillRef>
+          <a:effectRef idx="1">
+            <a:schemeClr val="accent1"/>
+          </a:effectRef>
+          <a:fontRef idx="minor">
+            <a:schemeClr val="tx1"/>
+          </a:fontRef>
+        </p:style>
+      </p:cxnSp>
+      <p:cxnSp>
+        <p:nvCxnSpPr>
+          <p:cNvPr id="37" name="Straight Connector 36">
+            <a:extLst>
+              <a:ext uri="{FF2B5EF4-FFF2-40B4-BE49-F238E27FC236}">
+                <a16:creationId xmlns:a16="http://schemas.microsoft.com/office/drawing/2014/main" id="{B2C81373-02D5-707C-ABFF-D758AD85A7F9}"/>
+              </a:ext>
+            </a:extLst>
+          </p:cNvPr>
+          <p:cNvCxnSpPr>
+            <a:cxnSpLocks/>
+            <a:stCxn id="26" idx="5"/>
+            <a:endCxn id="5" idx="1"/>
+          </p:cNvCxnSpPr>
+          <p:nvPr/>
+        </p:nvCxnSpPr>
+        <p:spPr>
+          <a:xfrm>
+            <a:off x="8511961" y="1572907"/>
+            <a:ext cx="1314104" cy="1449736"/>
+          </a:xfrm>
+          <a:prstGeom prst="line">
+            <a:avLst/>
+          </a:prstGeom>
+          <a:ln w="57150">
+            <a:solidFill>
+              <a:schemeClr val="tx1"/>
+            </a:solidFill>
+            <a:prstDash val="solid"/>
+          </a:ln>
+        </p:spPr>
+        <p:style>
+          <a:lnRef idx="2">
+            <a:schemeClr val="accent1"/>
+          </a:lnRef>
+          <a:fillRef idx="0">
+            <a:schemeClr val="accent1"/>
+          </a:fillRef>
+          <a:effectRef idx="1">
+            <a:schemeClr val="accent1"/>
+          </a:effectRef>
+          <a:fontRef idx="minor">
+            <a:schemeClr val="tx1"/>
+          </a:fontRef>
+        </p:style>
+      </p:cxnSp>
+      <p:cxnSp>
+        <p:nvCxnSpPr>
+          <p:cNvPr id="41" name="Straight Connector 40">
+            <a:extLst>
+              <a:ext uri="{FF2B5EF4-FFF2-40B4-BE49-F238E27FC236}">
+                <a16:creationId xmlns:a16="http://schemas.microsoft.com/office/drawing/2014/main" id="{8BA03549-78BE-715B-7B01-52577BF8E5B5}"/>
+              </a:ext>
+            </a:extLst>
+          </p:cNvPr>
+          <p:cNvCxnSpPr>
+            <a:cxnSpLocks/>
+            <a:stCxn id="23" idx="7"/>
+            <a:endCxn id="9" idx="2"/>
+          </p:cNvCxnSpPr>
+          <p:nvPr/>
+        </p:nvCxnSpPr>
+        <p:spPr>
+          <a:xfrm flipV="1">
+            <a:off x="3990761" y="3310601"/>
+            <a:ext cx="607045" cy="387240"/>
+          </a:xfrm>
+          <a:prstGeom prst="line">
+            <a:avLst/>
+          </a:prstGeom>
+          <a:ln w="57150">
+            <a:solidFill>
+              <a:schemeClr val="tx1"/>
+            </a:solidFill>
+            <a:prstDash val="solid"/>
+          </a:ln>
+        </p:spPr>
+        <p:style>
+          <a:lnRef idx="2">
+            <a:schemeClr val="accent1"/>
+          </a:lnRef>
+          <a:fillRef idx="0">
+            <a:schemeClr val="accent1"/>
+          </a:fillRef>
+          <a:effectRef idx="1">
+            <a:schemeClr val="accent1"/>
+          </a:effectRef>
+          <a:fontRef idx="minor">
+            <a:schemeClr val="tx1"/>
+          </a:fontRef>
+        </p:style>
+      </p:cxnSp>
+      <p:cxnSp>
+        <p:nvCxnSpPr>
+          <p:cNvPr id="44" name="Straight Connector 43">
+            <a:extLst>
+              <a:ext uri="{FF2B5EF4-FFF2-40B4-BE49-F238E27FC236}">
+                <a16:creationId xmlns:a16="http://schemas.microsoft.com/office/drawing/2014/main" id="{988D561F-297A-153D-8DB1-F769F4B4CF79}"/>
+              </a:ext>
+            </a:extLst>
+          </p:cNvPr>
+          <p:cNvCxnSpPr>
+            <a:cxnSpLocks/>
+            <a:stCxn id="23" idx="2"/>
+            <a:endCxn id="4" idx="5"/>
+          </p:cNvCxnSpPr>
+          <p:nvPr/>
+        </p:nvCxnSpPr>
+        <p:spPr>
+          <a:xfrm flipH="1" flipV="1">
+            <a:off x="2528495" y="3151961"/>
+            <a:ext cx="1306168" cy="610538"/>
+          </a:xfrm>
+          <a:prstGeom prst="line">
+            <a:avLst/>
+          </a:prstGeom>
+          <a:ln w="57150">
+            <a:solidFill>
+              <a:schemeClr val="tx1"/>
+            </a:solidFill>
+            <a:prstDash val="solid"/>
+          </a:ln>
+        </p:spPr>
+        <p:style>
+          <a:lnRef idx="2">
+            <a:schemeClr val="accent1"/>
+          </a:lnRef>
+          <a:fillRef idx="0">
+            <a:schemeClr val="accent1"/>
+          </a:fillRef>
+          <a:effectRef idx="1">
+            <a:schemeClr val="accent1"/>
+          </a:effectRef>
+          <a:fontRef idx="minor">
+            <a:schemeClr val="tx1"/>
+          </a:fontRef>
+        </p:style>
+      </p:cxnSp>
+    </p:spTree>
+    <p:extLst>
+      <p:ext uri="{BB962C8B-B14F-4D97-AF65-F5344CB8AC3E}">
+        <p14:creationId xmlns:p14="http://schemas.microsoft.com/office/powerpoint/2010/main" val="1228443015"/>
+      </p:ext>
+    </p:extLst>
+  </p:cSld>
+  <p:clrMapOvr>
+    <a:masterClrMapping/>
+  </p:clrMapOvr>
+</p:sld>
+</file>
+
+<file path=ppt/slides/slide25.xml><?xml version="1.0" encoding="utf-8"?>
+<p:sld xmlns:a="http://schemas.openxmlformats.org/drawingml/2006/main" xmlns:r="http://schemas.openxmlformats.org/officeDocument/2006/relationships" xmlns:p="http://schemas.openxmlformats.org/presentationml/2006/main">
+  <p:cSld>
+    <p:spTree>
+      <p:nvGrpSpPr>
+        <p:cNvPr id="1" name=""/>
+        <p:cNvGrpSpPr/>
+        <p:nvPr/>
+      </p:nvGrpSpPr>
+      <p:grpSpPr>
+        <a:xfrm>
+          <a:off x="0" y="0"/>
+          <a:ext cx="0" cy="0"/>
+          <a:chOff x="0" y="0"/>
+          <a:chExt cx="0" cy="0"/>
+        </a:xfrm>
+      </p:grpSpPr>
+      <p:pic>
+        <p:nvPicPr>
+          <p:cNvPr id="3" name="Picture 2" descr="A graph of a graph&#10;&#10;AI-generated content may be incorrect.">
+            <a:extLst>
+              <a:ext uri="{FF2B5EF4-FFF2-40B4-BE49-F238E27FC236}">
+                <a16:creationId xmlns:a16="http://schemas.microsoft.com/office/drawing/2014/main" id="{0F6FA1B0-ADCD-0C18-20A6-0D52AAF5BA2D}"/>
+              </a:ext>
+            </a:extLst>
+          </p:cNvPr>
+          <p:cNvPicPr>
+            <a:picLocks noChangeAspect="1"/>
+          </p:cNvPicPr>
+          <p:nvPr/>
+        </p:nvPicPr>
+        <p:blipFill>
+          <a:blip r:embed="rId2"/>
+          <a:stretch>
+            <a:fillRect/>
+          </a:stretch>
+        </p:blipFill>
+        <p:spPr>
+          <a:xfrm>
+            <a:off x="362366" y="1345565"/>
+            <a:ext cx="5285670" cy="4166870"/>
+          </a:xfrm>
+          <a:prstGeom prst="rect">
+            <a:avLst/>
+          </a:prstGeom>
+        </p:spPr>
+      </p:pic>
+      <p:pic>
+        <p:nvPicPr>
+          <p:cNvPr id="5" name="Picture 4" descr="A graph on a red and blue checkered surface&#10;&#10;AI-generated content may be incorrect.">
+            <a:extLst>
+              <a:ext uri="{FF2B5EF4-FFF2-40B4-BE49-F238E27FC236}">
+                <a16:creationId xmlns:a16="http://schemas.microsoft.com/office/drawing/2014/main" id="{9D2DDDDF-0377-16C0-1B6F-FAFFCB9017B6}"/>
+              </a:ext>
+            </a:extLst>
+          </p:cNvPr>
+          <p:cNvPicPr>
+            <a:picLocks noChangeAspect="1"/>
+          </p:cNvPicPr>
+          <p:nvPr/>
+        </p:nvPicPr>
+        <p:blipFill>
+          <a:blip r:embed="rId3"/>
+          <a:stretch>
+            <a:fillRect/>
+          </a:stretch>
+        </p:blipFill>
+        <p:spPr>
+          <a:xfrm>
+            <a:off x="6096000" y="1345565"/>
+            <a:ext cx="5285670" cy="4166870"/>
+          </a:xfrm>
+          <a:prstGeom prst="rect">
+            <a:avLst/>
+          </a:prstGeom>
+        </p:spPr>
+      </p:pic>
+    </p:spTree>
+    <p:extLst>
+      <p:ext uri="{BB962C8B-B14F-4D97-AF65-F5344CB8AC3E}">
+        <p14:creationId xmlns:p14="http://schemas.microsoft.com/office/powerpoint/2010/main" val="3559641924"/>
+      </p:ext>
+    </p:extLst>
+  </p:cSld>
+  <p:clrMapOvr>
+    <a:masterClrMapping/>
+  </p:clrMapOvr>
+</p:sld>
+</file>
+
+<file path=ppt/slides/slide26.xml><?xml version="1.0" encoding="utf-8"?>
+<p:sld xmlns:a="http://schemas.openxmlformats.org/drawingml/2006/main" xmlns:r="http://schemas.openxmlformats.org/officeDocument/2006/relationships" xmlns:p="http://schemas.openxmlformats.org/presentationml/2006/main">
+  <p:cSld>
+    <p:spTree>
+      <p:nvGrpSpPr>
+        <p:cNvPr id="1" name=""/>
+        <p:cNvGrpSpPr/>
+        <p:nvPr/>
+      </p:nvGrpSpPr>
+      <p:grpSpPr>
+        <a:xfrm>
+          <a:off x="0" y="0"/>
+          <a:ext cx="0" cy="0"/>
+          <a:chOff x="0" y="0"/>
+          <a:chExt cx="0" cy="0"/>
+        </a:xfrm>
+      </p:grpSpPr>
+    </p:spTree>
+    <p:extLst>
+      <p:ext uri="{BB962C8B-B14F-4D97-AF65-F5344CB8AC3E}">
+        <p14:creationId xmlns:p14="http://schemas.microsoft.com/office/powerpoint/2010/main" val="781196888"/>
       </p:ext>
     </p:extLst>
   </p:cSld>

</xml_diff>

<commit_message>
prep to take fully biased noise model data using current cd circuit with biased pauli channel post each two-qubit gate
</commit_message>
<xml_diff>
--- a/paper_diagrams/paper_scratch_images.pptx
+++ b/paper_diagrams/paper_scratch_images.pptx
@@ -5,7 +5,7 @@
     <p:sldMasterId id="2147483648" r:id="rId1"/>
   </p:sldMasterIdLst>
   <p:notesMasterIdLst>
-    <p:notesMasterId r:id="rId29"/>
+    <p:notesMasterId r:id="rId30"/>
   </p:notesMasterIdLst>
   <p:sldIdLst>
     <p:sldId id="257" r:id="rId2"/>
@@ -35,6 +35,7 @@
     <p:sldId id="283" r:id="rId26"/>
     <p:sldId id="284" r:id="rId27"/>
     <p:sldId id="285" r:id="rId28"/>
+    <p:sldId id="286" r:id="rId29"/>
   </p:sldIdLst>
   <p:sldSz cx="12192000" cy="6858000"/>
   <p:notesSz cx="6858000" cy="9144000"/>
@@ -223,7 +224,7 @@
           <a:p>
             <a:fld id="{50D6C3AD-5347-1148-888A-0C9F81FAA80E}" type="datetimeFigureOut">
               <a:rPr lang="en-US" smtClean="0"/>
-              <a:t>4/27/26</a:t>
+              <a:t>6/3/26</a:t>
             </a:fld>
             <a:endParaRPr lang="en-US"/>
           </a:p>
@@ -1777,7 +1778,7 @@
           <a:p>
             <a:fld id="{7E1AC42B-37F4-BE42-8540-9670643F9A86}" type="datetimeFigureOut">
               <a:rPr lang="en-US" smtClean="0"/>
-              <a:t>4/27/26</a:t>
+              <a:t>6/3/26</a:t>
             </a:fld>
             <a:endParaRPr lang="en-US"/>
           </a:p>
@@ -1975,7 +1976,7 @@
           <a:p>
             <a:fld id="{7E1AC42B-37F4-BE42-8540-9670643F9A86}" type="datetimeFigureOut">
               <a:rPr lang="en-US" smtClean="0"/>
-              <a:t>4/27/26</a:t>
+              <a:t>6/3/26</a:t>
             </a:fld>
             <a:endParaRPr lang="en-US"/>
           </a:p>
@@ -2183,7 +2184,7 @@
           <a:p>
             <a:fld id="{7E1AC42B-37F4-BE42-8540-9670643F9A86}" type="datetimeFigureOut">
               <a:rPr lang="en-US" smtClean="0"/>
-              <a:t>4/27/26</a:t>
+              <a:t>6/3/26</a:t>
             </a:fld>
             <a:endParaRPr lang="en-US"/>
           </a:p>
@@ -2381,7 +2382,7 @@
           <a:p>
             <a:fld id="{7E1AC42B-37F4-BE42-8540-9670643F9A86}" type="datetimeFigureOut">
               <a:rPr lang="en-US" smtClean="0"/>
-              <a:t>4/27/26</a:t>
+              <a:t>6/3/26</a:t>
             </a:fld>
             <a:endParaRPr lang="en-US"/>
           </a:p>
@@ -2656,7 +2657,7 @@
           <a:p>
             <a:fld id="{7E1AC42B-37F4-BE42-8540-9670643F9A86}" type="datetimeFigureOut">
               <a:rPr lang="en-US" smtClean="0"/>
-              <a:t>4/27/26</a:t>
+              <a:t>6/3/26</a:t>
             </a:fld>
             <a:endParaRPr lang="en-US"/>
           </a:p>
@@ -2921,7 +2922,7 @@
           <a:p>
             <a:fld id="{7E1AC42B-37F4-BE42-8540-9670643F9A86}" type="datetimeFigureOut">
               <a:rPr lang="en-US" smtClean="0"/>
-              <a:t>4/27/26</a:t>
+              <a:t>6/3/26</a:t>
             </a:fld>
             <a:endParaRPr lang="en-US"/>
           </a:p>
@@ -3333,7 +3334,7 @@
           <a:p>
             <a:fld id="{7E1AC42B-37F4-BE42-8540-9670643F9A86}" type="datetimeFigureOut">
               <a:rPr lang="en-US" smtClean="0"/>
-              <a:t>4/27/26</a:t>
+              <a:t>6/3/26</a:t>
             </a:fld>
             <a:endParaRPr lang="en-US"/>
           </a:p>
@@ -3474,7 +3475,7 @@
           <a:p>
             <a:fld id="{7E1AC42B-37F4-BE42-8540-9670643F9A86}" type="datetimeFigureOut">
               <a:rPr lang="en-US" smtClean="0"/>
-              <a:t>4/27/26</a:t>
+              <a:t>6/3/26</a:t>
             </a:fld>
             <a:endParaRPr lang="en-US"/>
           </a:p>
@@ -3587,7 +3588,7 @@
           <a:p>
             <a:fld id="{7E1AC42B-37F4-BE42-8540-9670643F9A86}" type="datetimeFigureOut">
               <a:rPr lang="en-US" smtClean="0"/>
-              <a:t>4/27/26</a:t>
+              <a:t>6/3/26</a:t>
             </a:fld>
             <a:endParaRPr lang="en-US"/>
           </a:p>
@@ -3898,7 +3899,7 @@
           <a:p>
             <a:fld id="{7E1AC42B-37F4-BE42-8540-9670643F9A86}" type="datetimeFigureOut">
               <a:rPr lang="en-US" smtClean="0"/>
-              <a:t>4/27/26</a:t>
+              <a:t>6/3/26</a:t>
             </a:fld>
             <a:endParaRPr lang="en-US"/>
           </a:p>
@@ -4186,7 +4187,7 @@
           <a:p>
             <a:fld id="{7E1AC42B-37F4-BE42-8540-9670643F9A86}" type="datetimeFigureOut">
               <a:rPr lang="en-US" smtClean="0"/>
-              <a:t>4/27/26</a:t>
+              <a:t>6/3/26</a:t>
             </a:fld>
             <a:endParaRPr lang="en-US"/>
           </a:p>
@@ -4427,7 +4428,7 @@
           <a:p>
             <a:fld id="{7E1AC42B-37F4-BE42-8540-9670643F9A86}" type="datetimeFigureOut">
               <a:rPr lang="en-US" smtClean="0"/>
-              <a:t>4/27/26</a:t>
+              <a:t>6/3/26</a:t>
             </a:fld>
             <a:endParaRPr lang="en-US"/>
           </a:p>
@@ -21853,8 +21854,8 @@
           </a:prstGeom>
         </p:spPr>
       </p:pic>
-      <mc:AlternateContent xmlns:mc="http://schemas.openxmlformats.org/markup-compatibility/2006">
-        <mc:Choice xmlns:a14="http://schemas.microsoft.com/office/drawing/2010/main" Requires="a14">
+      <mc:AlternateContent xmlns:mc="http://schemas.openxmlformats.org/markup-compatibility/2006" xmlns:a14="http://schemas.microsoft.com/office/drawing/2010/main">
+        <mc:Choice Requires="a14">
           <p:sp>
             <p:nvSpPr>
               <p:cNvPr id="4" name="Rectangle 3">
@@ -21933,7 +21934,7 @@
             </p:txBody>
           </p:sp>
         </mc:Choice>
-        <mc:Fallback>
+        <mc:Fallback xmlns="">
           <p:sp>
             <p:nvSpPr>
               <p:cNvPr id="4" name="Rectangle 3">
@@ -21985,6 +21986,103 @@
     <p:extLst>
       <p:ext uri="{BB962C8B-B14F-4D97-AF65-F5344CB8AC3E}">
         <p14:creationId xmlns:p14="http://schemas.microsoft.com/office/powerpoint/2010/main" val="4241644651"/>
+      </p:ext>
+    </p:extLst>
+  </p:cSld>
+  <p:clrMapOvr>
+    <a:masterClrMapping/>
+  </p:clrMapOvr>
+</p:sld>
+</file>
+
+<file path=ppt/slides/slide28.xml><?xml version="1.0" encoding="utf-8"?>
+<p:sld xmlns:a="http://schemas.openxmlformats.org/drawingml/2006/main" xmlns:r="http://schemas.openxmlformats.org/officeDocument/2006/relationships" xmlns:p="http://schemas.openxmlformats.org/presentationml/2006/main">
+  <p:cSld>
+    <p:spTree>
+      <p:nvGrpSpPr>
+        <p:cNvPr id="1" name=""/>
+        <p:cNvGrpSpPr/>
+        <p:nvPr/>
+      </p:nvGrpSpPr>
+      <p:grpSpPr>
+        <a:xfrm>
+          <a:off x="0" y="0"/>
+          <a:ext cx="0" cy="0"/>
+          <a:chOff x="0" y="0"/>
+          <a:chExt cx="0" cy="0"/>
+        </a:xfrm>
+      </p:grpSpPr>
+      <p:pic>
+        <p:nvPicPr>
+          <p:cNvPr id="3" name="Graphic 2">
+            <a:extLst>
+              <a:ext uri="{FF2B5EF4-FFF2-40B4-BE49-F238E27FC236}">
+                <a16:creationId xmlns:a16="http://schemas.microsoft.com/office/drawing/2014/main" id="{DCA68067-F6ED-C472-23F3-60F1BEAB5837}"/>
+              </a:ext>
+            </a:extLst>
+          </p:cNvPr>
+          <p:cNvPicPr>
+            <a:picLocks noChangeAspect="1"/>
+          </p:cNvPicPr>
+          <p:nvPr/>
+        </p:nvPicPr>
+        <p:blipFill>
+          <a:blip>
+            <a:extLst>
+              <a:ext uri="{96DAC541-7B7A-43D3-8B79-37D633B846F1}">
+                <asvg:svgBlip xmlns:asvg="http://schemas.microsoft.com/office/drawing/2016/SVG/main" r:embed="rId2"/>
+              </a:ext>
+            </a:extLst>
+          </a:blip>
+          <a:stretch>
+            <a:fillRect/>
+          </a:stretch>
+        </p:blipFill>
+        <p:spPr>
+          <a:xfrm>
+            <a:off x="127893" y="1349568"/>
+            <a:ext cx="4750150" cy="4750150"/>
+          </a:xfrm>
+          <a:prstGeom prst="rect">
+            <a:avLst/>
+          </a:prstGeom>
+        </p:spPr>
+      </p:pic>
+      <p:pic>
+        <p:nvPicPr>
+          <p:cNvPr id="5" name="Picture 4">
+            <a:extLst>
+              <a:ext uri="{FF2B5EF4-FFF2-40B4-BE49-F238E27FC236}">
+                <a16:creationId xmlns:a16="http://schemas.microsoft.com/office/drawing/2014/main" id="{8E0609BC-DB87-7683-C06A-54E63EF9BDE4}"/>
+              </a:ext>
+            </a:extLst>
+          </p:cNvPr>
+          <p:cNvPicPr>
+            <a:picLocks noChangeAspect="1"/>
+          </p:cNvPicPr>
+          <p:nvPr/>
+        </p:nvPicPr>
+        <p:blipFill>
+          <a:blip r:embed="rId3"/>
+          <a:srcRect l="2900" r="5364"/>
+          <a:stretch>
+            <a:fillRect/>
+          </a:stretch>
+        </p:blipFill>
+        <p:spPr>
+          <a:xfrm>
+            <a:off x="4847759" y="1003879"/>
+            <a:ext cx="7049083" cy="4850242"/>
+          </a:xfrm>
+          <a:prstGeom prst="rect">
+            <a:avLst/>
+          </a:prstGeom>
+        </p:spPr>
+      </p:pic>
+    </p:spTree>
+    <p:extLst>
+      <p:ext uri="{BB962C8B-B14F-4D97-AF65-F5344CB8AC3E}">
+        <p14:creationId xmlns:p14="http://schemas.microsoft.com/office/powerpoint/2010/main" val="1814509821"/>
       </p:ext>
     </p:extLst>
   </p:cSld>

</xml_diff>